<commit_message>
- regenerated art access and layers - added stubs for unimplemented mace, trident and spear things - generalized path finding alg for different crystal implementations - upgraded fusing animation to include shaking - added level render mixin to interface with item renderer to make items rotate in real tiem during fusion anim for players
</commit_message>
<xml_diff>
--- a/art/archeology_sample.pptx
+++ b/art/archeology_sample.pptx
@@ -6,6 +6,7 @@
   </p:sldMasterIdLst>
   <p:sldIdLst>
     <p:sldId id="256" r:id="rId2"/>
+    <p:sldId id="257" r:id="rId3"/>
   </p:sldIdLst>
   <p:sldSz cx="12192000" cy="6858000"/>
   <p:notesSz cx="6858000" cy="9144000"/>
@@ -104,6 +105,11 @@
       </a:defRPr>
     </a:lvl9pPr>
   </p:defaultTextStyle>
+  <p:extLst>
+    <p:ext uri="{EFAFB233-063F-42B5-8137-9DF3F51BA10A}">
+      <p15:sldGuideLst xmlns:p15="http://schemas.microsoft.com/office/powerpoint/2012/main"/>
+    </p:ext>
+  </p:extLst>
 </p:presentation>
 </file>
 
@@ -254,7 +260,7 @@
           <a:p>
             <a:fld id="{2176CA67-A27D-4035-BF4E-DF5A4677C9A9}" type="datetimeFigureOut">
               <a:rPr lang="en-US" smtClean="0"/>
-              <a:t>8/11/2026</a:t>
+              <a:t>8/30/2026</a:t>
             </a:fld>
             <a:endParaRPr lang="en-US"/>
           </a:p>
@@ -452,7 +458,7 @@
           <a:p>
             <a:fld id="{2176CA67-A27D-4035-BF4E-DF5A4677C9A9}" type="datetimeFigureOut">
               <a:rPr lang="en-US" smtClean="0"/>
-              <a:t>8/11/2026</a:t>
+              <a:t>8/30/2026</a:t>
             </a:fld>
             <a:endParaRPr lang="en-US"/>
           </a:p>
@@ -660,7 +666,7 @@
           <a:p>
             <a:fld id="{2176CA67-A27D-4035-BF4E-DF5A4677C9A9}" type="datetimeFigureOut">
               <a:rPr lang="en-US" smtClean="0"/>
-              <a:t>8/11/2026</a:t>
+              <a:t>8/30/2026</a:t>
             </a:fld>
             <a:endParaRPr lang="en-US"/>
           </a:p>
@@ -858,7 +864,7 @@
           <a:p>
             <a:fld id="{2176CA67-A27D-4035-BF4E-DF5A4677C9A9}" type="datetimeFigureOut">
               <a:rPr lang="en-US" smtClean="0"/>
-              <a:t>8/11/2026</a:t>
+              <a:t>8/30/2026</a:t>
             </a:fld>
             <a:endParaRPr lang="en-US"/>
           </a:p>
@@ -1133,7 +1139,7 @@
           <a:p>
             <a:fld id="{2176CA67-A27D-4035-BF4E-DF5A4677C9A9}" type="datetimeFigureOut">
               <a:rPr lang="en-US" smtClean="0"/>
-              <a:t>8/11/2026</a:t>
+              <a:t>8/30/2026</a:t>
             </a:fld>
             <a:endParaRPr lang="en-US"/>
           </a:p>
@@ -1398,7 +1404,7 @@
           <a:p>
             <a:fld id="{2176CA67-A27D-4035-BF4E-DF5A4677C9A9}" type="datetimeFigureOut">
               <a:rPr lang="en-US" smtClean="0"/>
-              <a:t>8/11/2026</a:t>
+              <a:t>8/30/2026</a:t>
             </a:fld>
             <a:endParaRPr lang="en-US"/>
           </a:p>
@@ -1810,7 +1816,7 @@
           <a:p>
             <a:fld id="{2176CA67-A27D-4035-BF4E-DF5A4677C9A9}" type="datetimeFigureOut">
               <a:rPr lang="en-US" smtClean="0"/>
-              <a:t>8/11/2026</a:t>
+              <a:t>8/30/2026</a:t>
             </a:fld>
             <a:endParaRPr lang="en-US"/>
           </a:p>
@@ -1951,7 +1957,7 @@
           <a:p>
             <a:fld id="{2176CA67-A27D-4035-BF4E-DF5A4677C9A9}" type="datetimeFigureOut">
               <a:rPr lang="en-US" smtClean="0"/>
-              <a:t>8/11/2026</a:t>
+              <a:t>8/30/2026</a:t>
             </a:fld>
             <a:endParaRPr lang="en-US"/>
           </a:p>
@@ -2064,7 +2070,7 @@
           <a:p>
             <a:fld id="{2176CA67-A27D-4035-BF4E-DF5A4677C9A9}" type="datetimeFigureOut">
               <a:rPr lang="en-US" smtClean="0"/>
-              <a:t>8/11/2026</a:t>
+              <a:t>8/30/2026</a:t>
             </a:fld>
             <a:endParaRPr lang="en-US"/>
           </a:p>
@@ -2375,7 +2381,7 @@
           <a:p>
             <a:fld id="{2176CA67-A27D-4035-BF4E-DF5A4677C9A9}" type="datetimeFigureOut">
               <a:rPr lang="en-US" smtClean="0"/>
-              <a:t>8/11/2026</a:t>
+              <a:t>8/30/2026</a:t>
             </a:fld>
             <a:endParaRPr lang="en-US"/>
           </a:p>
@@ -2663,7 +2669,7 @@
           <a:p>
             <a:fld id="{2176CA67-A27D-4035-BF4E-DF5A4677C9A9}" type="datetimeFigureOut">
               <a:rPr lang="en-US" smtClean="0"/>
-              <a:t>8/11/2026</a:t>
+              <a:t>8/30/2026</a:t>
             </a:fld>
             <a:endParaRPr lang="en-US"/>
           </a:p>
@@ -2904,7 +2910,7 @@
           <a:p>
             <a:fld id="{2176CA67-A27D-4035-BF4E-DF5A4677C9A9}" type="datetimeFigureOut">
               <a:rPr lang="en-US" smtClean="0"/>
-              <a:t>8/11/2026</a:t>
+              <a:t>8/30/2026</a:t>
             </a:fld>
             <a:endParaRPr lang="en-US"/>
           </a:p>
@@ -4618,6 +4624,253 @@
 </p:sld>
 </file>
 
+<file path=ppt/slides/slide2.xml><?xml version="1.0" encoding="utf-8"?>
+<p:sld xmlns:a="http://schemas.openxmlformats.org/drawingml/2006/main" xmlns:r="http://schemas.openxmlformats.org/officeDocument/2006/relationships" xmlns:p="http://schemas.openxmlformats.org/presentationml/2006/main">
+  <p:cSld>
+    <p:spTree>
+      <p:nvGrpSpPr>
+        <p:cNvPr id="1" name=""/>
+        <p:cNvGrpSpPr/>
+        <p:nvPr/>
+      </p:nvGrpSpPr>
+      <p:grpSpPr>
+        <a:xfrm>
+          <a:off x="0" y="0"/>
+          <a:ext cx="0" cy="0"/>
+          <a:chOff x="0" y="0"/>
+          <a:chExt cx="0" cy="0"/>
+        </a:xfrm>
+      </p:grpSpPr>
+      <p:pic>
+        <p:nvPicPr>
+          <p:cNvPr id="5" name="Picture 4">
+            <a:extLst>
+              <a:ext uri="{FF2B5EF4-FFF2-40B4-BE49-F238E27FC236}">
+                <a16:creationId xmlns:a16="http://schemas.microsoft.com/office/drawing/2014/main" id="{595409C1-F250-3775-333E-F7A8CBD9E5E5}"/>
+              </a:ext>
+            </a:extLst>
+          </p:cNvPr>
+          <p:cNvPicPr>
+            <a:picLocks noChangeAspect="1"/>
+          </p:cNvPicPr>
+          <p:nvPr/>
+        </p:nvPicPr>
+        <p:blipFill>
+          <a:blip r:embed="rId2">
+            <a:extLst>
+              <a:ext uri="{28A0092B-C50C-407E-A947-70E740481C1C}">
+                <a14:useLocalDpi xmlns:a14="http://schemas.microsoft.com/office/drawing/2010/main" val="0"/>
+              </a:ext>
+            </a:extLst>
+          </a:blip>
+          <a:stretch>
+            <a:fillRect/>
+          </a:stretch>
+        </p:blipFill>
+        <p:spPr>
+          <a:xfrm rot="4873830">
+            <a:off x="2894938" y="1959766"/>
+            <a:ext cx="1915602" cy="1915602"/>
+          </a:xfrm>
+          <a:prstGeom prst="rect">
+            <a:avLst/>
+          </a:prstGeom>
+        </p:spPr>
+      </p:pic>
+      <p:pic>
+        <p:nvPicPr>
+          <p:cNvPr id="7" name="Picture 6">
+            <a:extLst>
+              <a:ext uri="{FF2B5EF4-FFF2-40B4-BE49-F238E27FC236}">
+                <a16:creationId xmlns:a16="http://schemas.microsoft.com/office/drawing/2014/main" id="{F3AED748-CF1C-3AA6-9518-E19DFF85563E}"/>
+              </a:ext>
+            </a:extLst>
+          </p:cNvPr>
+          <p:cNvPicPr>
+            <a:picLocks noChangeAspect="1"/>
+          </p:cNvPicPr>
+          <p:nvPr/>
+        </p:nvPicPr>
+        <p:blipFill>
+          <a:blip r:embed="rId3">
+            <a:extLst>
+              <a:ext uri="{28A0092B-C50C-407E-A947-70E740481C1C}">
+                <a14:useLocalDpi xmlns:a14="http://schemas.microsoft.com/office/drawing/2010/main" val="0"/>
+              </a:ext>
+            </a:extLst>
+          </a:blip>
+          <a:stretch>
+            <a:fillRect/>
+          </a:stretch>
+        </p:blipFill>
+        <p:spPr>
+          <a:xfrm rot="18533028">
+            <a:off x="1525522" y="885006"/>
+            <a:ext cx="2007080" cy="2007080"/>
+          </a:xfrm>
+          <a:prstGeom prst="rect">
+            <a:avLst/>
+          </a:prstGeom>
+        </p:spPr>
+      </p:pic>
+      <p:pic>
+        <p:nvPicPr>
+          <p:cNvPr id="9" name="Picture 8">
+            <a:extLst>
+              <a:ext uri="{FF2B5EF4-FFF2-40B4-BE49-F238E27FC236}">
+                <a16:creationId xmlns:a16="http://schemas.microsoft.com/office/drawing/2014/main" id="{EBF74A91-FA90-5590-87AB-4E1185D787C2}"/>
+              </a:ext>
+            </a:extLst>
+          </p:cNvPr>
+          <p:cNvPicPr>
+            <a:picLocks noChangeAspect="1"/>
+          </p:cNvPicPr>
+          <p:nvPr/>
+        </p:nvPicPr>
+        <p:blipFill>
+          <a:blip r:embed="rId3">
+            <a:extLst>
+              <a:ext uri="{28A0092B-C50C-407E-A947-70E740481C1C}">
+                <a14:useLocalDpi xmlns:a14="http://schemas.microsoft.com/office/drawing/2010/main" val="0"/>
+              </a:ext>
+            </a:extLst>
+          </a:blip>
+          <a:stretch>
+            <a:fillRect/>
+          </a:stretch>
+        </p:blipFill>
+        <p:spPr>
+          <a:xfrm rot="2230541">
+            <a:off x="8142478" y="920839"/>
+            <a:ext cx="1367367" cy="1367367"/>
+          </a:xfrm>
+          <a:prstGeom prst="rect">
+            <a:avLst/>
+          </a:prstGeom>
+        </p:spPr>
+      </p:pic>
+      <p:cxnSp>
+        <p:nvCxnSpPr>
+          <p:cNvPr id="11" name="Straight Connector 10">
+            <a:extLst>
+              <a:ext uri="{FF2B5EF4-FFF2-40B4-BE49-F238E27FC236}">
+                <a16:creationId xmlns:a16="http://schemas.microsoft.com/office/drawing/2014/main" id="{3883A58D-746E-24CD-DECB-9414D54065E1}"/>
+              </a:ext>
+            </a:extLst>
+          </p:cNvPr>
+          <p:cNvCxnSpPr/>
+          <p:nvPr/>
+        </p:nvCxnSpPr>
+        <p:spPr>
+          <a:xfrm flipV="1">
+            <a:off x="8644713" y="1346095"/>
+            <a:ext cx="1574358" cy="1693628"/>
+          </a:xfrm>
+          <a:prstGeom prst="line">
+            <a:avLst/>
+          </a:prstGeom>
+          <a:ln w="28575"/>
+        </p:spPr>
+        <p:style>
+          <a:lnRef idx="1">
+            <a:schemeClr val="dk1"/>
+          </a:lnRef>
+          <a:fillRef idx="0">
+            <a:schemeClr val="dk1"/>
+          </a:fillRef>
+          <a:effectRef idx="0">
+            <a:schemeClr val="dk1"/>
+          </a:effectRef>
+          <a:fontRef idx="minor">
+            <a:schemeClr val="tx1"/>
+          </a:fontRef>
+        </p:style>
+      </p:cxnSp>
+      <p:pic>
+        <p:nvPicPr>
+          <p:cNvPr id="6" name="Picture 5">
+            <a:extLst>
+              <a:ext uri="{FF2B5EF4-FFF2-40B4-BE49-F238E27FC236}">
+                <a16:creationId xmlns:a16="http://schemas.microsoft.com/office/drawing/2014/main" id="{8C4EC2B1-3CF9-E032-E586-192334E0CA9C}"/>
+              </a:ext>
+            </a:extLst>
+          </p:cNvPr>
+          <p:cNvPicPr>
+            <a:picLocks noChangeAspect="1"/>
+          </p:cNvPicPr>
+          <p:nvPr/>
+        </p:nvPicPr>
+        <p:blipFill>
+          <a:blip r:embed="rId4">
+            <a:extLst>
+              <a:ext uri="{28A0092B-C50C-407E-A947-70E740481C1C}">
+                <a14:useLocalDpi xmlns:a14="http://schemas.microsoft.com/office/drawing/2010/main" val="0"/>
+              </a:ext>
+            </a:extLst>
+          </a:blip>
+          <a:stretch>
+            <a:fillRect/>
+          </a:stretch>
+        </p:blipFill>
+        <p:spPr>
+          <a:xfrm>
+            <a:off x="4144804" y="2228690"/>
+            <a:ext cx="3902392" cy="3914344"/>
+          </a:xfrm>
+          <a:prstGeom prst="rect">
+            <a:avLst/>
+          </a:prstGeom>
+        </p:spPr>
+      </p:pic>
+      <p:pic>
+        <p:nvPicPr>
+          <p:cNvPr id="8" name="Picture 7">
+            <a:extLst>
+              <a:ext uri="{FF2B5EF4-FFF2-40B4-BE49-F238E27FC236}">
+                <a16:creationId xmlns:a16="http://schemas.microsoft.com/office/drawing/2014/main" id="{88549A1F-A0A6-75AF-ABFD-B9212C9C84D4}"/>
+              </a:ext>
+            </a:extLst>
+          </p:cNvPr>
+          <p:cNvPicPr>
+            <a:picLocks noChangeAspect="1"/>
+          </p:cNvPicPr>
+          <p:nvPr/>
+        </p:nvPicPr>
+        <p:blipFill>
+          <a:blip r:embed="rId2">
+            <a:extLst>
+              <a:ext uri="{28A0092B-C50C-407E-A947-70E740481C1C}">
+                <a14:useLocalDpi xmlns:a14="http://schemas.microsoft.com/office/drawing/2010/main" val="0"/>
+              </a:ext>
+            </a:extLst>
+          </a:blip>
+          <a:stretch>
+            <a:fillRect/>
+          </a:stretch>
+        </p:blipFill>
+        <p:spPr>
+          <a:xfrm rot="20269521">
+            <a:off x="5062040" y="3210546"/>
+            <a:ext cx="2067917" cy="2067917"/>
+          </a:xfrm>
+          <a:prstGeom prst="rect">
+            <a:avLst/>
+          </a:prstGeom>
+        </p:spPr>
+      </p:pic>
+    </p:spTree>
+    <p:extLst>
+      <p:ext uri="{BB962C8B-B14F-4D97-AF65-F5344CB8AC3E}">
+        <p14:creationId xmlns:p14="http://schemas.microsoft.com/office/powerpoint/2010/main" val="4155577010"/>
+      </p:ext>
+    </p:extLst>
+  </p:cSld>
+  <p:clrMapOvr>
+    <a:masterClrMapping/>
+  </p:clrMapOvr>
+</p:sld>
+</file>
+
 <file path=ppt/theme/theme1.xml><?xml version="1.0" encoding="utf-8"?>
 <a:theme xmlns:a="http://schemas.openxmlformats.org/drawingml/2006/main" name="Office Theme">
   <a:themeElements>

</xml_diff>